<commit_message>
docs: add 8th slide (Parameter Correlation Matrix) to presentation
</commit_message>
<xml_diff>
--- a/AttriSense_AI_Jury_Presentation.pptx
+++ b/AttriSense_AI_Jury_Presentation.pptx
@@ -5,15 +5,15 @@
     <p:sldMasterId id="2147483648" r:id="rId1"/>
   </p:sldMasterIdLst>
   <p:sldIdLst>
-    <p:sldId id="256" r:id="rId7"/>
-    <p:sldId id="257" r:id="rId8"/>
-    <p:sldId id="258" r:id="rId9"/>
-    <p:sldId id="259" r:id="rId10"/>
-    <p:sldId id="260" r:id="rId11"/>
-    <p:sldId id="261" r:id="rId12"/>
-    <p:sldId id="262" r:id="rId13"/>
+    <p:sldId id="256" r:id="rId2"/>
+    <p:sldId id="257" r:id="rId3"/>
+    <p:sldId id="258" r:id="rId4"/>
+    <p:sldId id="259" r:id="rId5"/>
+    <p:sldId id="260" r:id="rId6"/>
+    <p:sldId id="261" r:id="rId7"/>
+    <p:sldId id="262" r:id="rId8"/>
   </p:sldIdLst>
-  <p:sldSz cx="12191695" cy="6858000" type="screen4x3"/>
+  <p:sldSz cx="12192000" cy="6858000"/>
   <p:notesSz cx="6858000" cy="9144000"/>
   <p:defaultTextStyle>
     <a:defPPr>
@@ -110,6 +110,22 @@
       </a:defRPr>
     </a:lvl9pPr>
   </p:defaultTextStyle>
+  <p:extLst>
+    <p:ext uri="{EFAFB233-063F-42B5-8137-9DF3F51BA10A}">
+      <p15:sldGuideLst xmlns:p15="http://schemas.microsoft.com/office/powerpoint/2012/main">
+        <p15:guide id="1" orient="horz" pos="2160">
+          <p15:clr>
+            <a:srgbClr val="A4A3A4"/>
+          </p15:clr>
+        </p15:guide>
+        <p15:guide id="2" pos="2880">
+          <p15:clr>
+            <a:srgbClr val="A4A3A4"/>
+          </p15:clr>
+        </p15:guide>
+      </p15:sldGuideLst>
+    </p:ext>
+  </p:extLst>
 </p:presentation>
 </file>
 
@@ -151,10 +167,9 @@
           <a:lstStyle/>
           <a:p>
             <a:r>
-              <a:rPr lang="en-US" smtClean="0"/>
+              <a:rPr lang="en-US"/>
               <a:t>Click to edit Master title style</a:t>
             </a:r>
-            <a:endParaRPr lang="en-US"/>
           </a:p>
         </p:txBody>
       </p:sp>
@@ -270,10 +285,9 @@
           </a:lstStyle>
           <a:p>
             <a:r>
-              <a:rPr lang="en-US" smtClean="0"/>
+              <a:rPr lang="en-US"/>
               <a:t>Click to edit Master subtitle style</a:t>
             </a:r>
-            <a:endParaRPr lang="en-US"/>
           </a:p>
         </p:txBody>
       </p:sp>
@@ -294,7 +308,7 @@
           <a:p>
             <a:fld id="{5BCAD085-E8A6-8845-BD4E-CB4CCA059FC4}" type="datetimeFigureOut">
               <a:rPr lang="en-US" smtClean="0"/>
-              <a:t>1/27/13</a:t>
+              <a:t>7/9/2026</a:t>
             </a:fld>
             <a:endParaRPr lang="en-US"/>
           </a:p>
@@ -388,10 +402,9 @@
           <a:lstStyle/>
           <a:p>
             <a:r>
-              <a:rPr lang="en-US" smtClean="0"/>
+              <a:rPr lang="en-US"/>
               <a:t>Click to edit Master title style</a:t>
             </a:r>
-            <a:endParaRPr lang="en-US"/>
           </a:p>
         </p:txBody>
       </p:sp>
@@ -412,38 +425,37 @@
           <a:p>
             <a:pPr lvl="0"/>
             <a:r>
-              <a:rPr lang="en-US" smtClean="0"/>
+              <a:rPr lang="en-US"/>
               <a:t>Click to edit Master text styles</a:t>
             </a:r>
           </a:p>
           <a:p>
             <a:pPr lvl="1"/>
             <a:r>
-              <a:rPr lang="en-US" smtClean="0"/>
+              <a:rPr lang="en-US"/>
               <a:t>Second level</a:t>
             </a:r>
           </a:p>
           <a:p>
             <a:pPr lvl="2"/>
             <a:r>
-              <a:rPr lang="en-US" smtClean="0"/>
+              <a:rPr lang="en-US"/>
               <a:t>Third level</a:t>
             </a:r>
           </a:p>
           <a:p>
             <a:pPr lvl="3"/>
             <a:r>
-              <a:rPr lang="en-US" smtClean="0"/>
+              <a:rPr lang="en-US"/>
               <a:t>Fourth level</a:t>
             </a:r>
           </a:p>
           <a:p>
             <a:pPr lvl="4"/>
             <a:r>
-              <a:rPr lang="en-US" smtClean="0"/>
+              <a:rPr lang="en-US"/>
               <a:t>Fifth level</a:t>
             </a:r>
-            <a:endParaRPr lang="en-US"/>
           </a:p>
         </p:txBody>
       </p:sp>
@@ -464,7 +476,7 @@
           <a:p>
             <a:fld id="{5BCAD085-E8A6-8845-BD4E-CB4CCA059FC4}" type="datetimeFigureOut">
               <a:rPr lang="en-US" smtClean="0"/>
-              <a:t>1/27/13</a:t>
+              <a:t>7/9/2026</a:t>
             </a:fld>
             <a:endParaRPr lang="en-US"/>
           </a:p>
@@ -563,10 +575,9 @@
           <a:lstStyle/>
           <a:p>
             <a:r>
-              <a:rPr lang="en-US" smtClean="0"/>
+              <a:rPr lang="en-US"/>
               <a:t>Click to edit Master title style</a:t>
             </a:r>
-            <a:endParaRPr lang="en-US"/>
           </a:p>
         </p:txBody>
       </p:sp>
@@ -592,38 +603,37 @@
           <a:p>
             <a:pPr lvl="0"/>
             <a:r>
-              <a:rPr lang="en-US" smtClean="0"/>
+              <a:rPr lang="en-US"/>
               <a:t>Click to edit Master text styles</a:t>
             </a:r>
           </a:p>
           <a:p>
             <a:pPr lvl="1"/>
             <a:r>
-              <a:rPr lang="en-US" smtClean="0"/>
+              <a:rPr lang="en-US"/>
               <a:t>Second level</a:t>
             </a:r>
           </a:p>
           <a:p>
             <a:pPr lvl="2"/>
             <a:r>
-              <a:rPr lang="en-US" smtClean="0"/>
+              <a:rPr lang="en-US"/>
               <a:t>Third level</a:t>
             </a:r>
           </a:p>
           <a:p>
             <a:pPr lvl="3"/>
             <a:r>
-              <a:rPr lang="en-US" smtClean="0"/>
+              <a:rPr lang="en-US"/>
               <a:t>Fourth level</a:t>
             </a:r>
           </a:p>
           <a:p>
             <a:pPr lvl="4"/>
             <a:r>
-              <a:rPr lang="en-US" smtClean="0"/>
+              <a:rPr lang="en-US"/>
               <a:t>Fifth level</a:t>
             </a:r>
-            <a:endParaRPr lang="en-US"/>
           </a:p>
         </p:txBody>
       </p:sp>
@@ -644,7 +654,7 @@
           <a:p>
             <a:fld id="{5BCAD085-E8A6-8845-BD4E-CB4CCA059FC4}" type="datetimeFigureOut">
               <a:rPr lang="en-US" smtClean="0"/>
-              <a:t>1/27/13</a:t>
+              <a:t>7/9/2026</a:t>
             </a:fld>
             <a:endParaRPr lang="en-US"/>
           </a:p>
@@ -738,10 +748,9 @@
           <a:lstStyle/>
           <a:p>
             <a:r>
-              <a:rPr lang="en-US" smtClean="0"/>
+              <a:rPr lang="en-US"/>
               <a:t>Click to edit Master title style</a:t>
             </a:r>
-            <a:endParaRPr lang="en-US"/>
           </a:p>
         </p:txBody>
       </p:sp>
@@ -762,38 +771,37 @@
           <a:p>
             <a:pPr lvl="0"/>
             <a:r>
-              <a:rPr lang="en-US" smtClean="0"/>
+              <a:rPr lang="en-US"/>
               <a:t>Click to edit Master text styles</a:t>
             </a:r>
           </a:p>
           <a:p>
             <a:pPr lvl="1"/>
             <a:r>
-              <a:rPr lang="en-US" smtClean="0"/>
+              <a:rPr lang="en-US"/>
               <a:t>Second level</a:t>
             </a:r>
           </a:p>
           <a:p>
             <a:pPr lvl="2"/>
             <a:r>
-              <a:rPr lang="en-US" smtClean="0"/>
+              <a:rPr lang="en-US"/>
               <a:t>Third level</a:t>
             </a:r>
           </a:p>
           <a:p>
             <a:pPr lvl="3"/>
             <a:r>
-              <a:rPr lang="en-US" smtClean="0"/>
+              <a:rPr lang="en-US"/>
               <a:t>Fourth level</a:t>
             </a:r>
           </a:p>
           <a:p>
             <a:pPr lvl="4"/>
             <a:r>
-              <a:rPr lang="en-US" smtClean="0"/>
+              <a:rPr lang="en-US"/>
               <a:t>Fifth level</a:t>
             </a:r>
-            <a:endParaRPr lang="en-US"/>
           </a:p>
         </p:txBody>
       </p:sp>
@@ -814,7 +822,7 @@
           <a:p>
             <a:fld id="{5BCAD085-E8A6-8845-BD4E-CB4CCA059FC4}" type="datetimeFigureOut">
               <a:rPr lang="en-US" smtClean="0"/>
-              <a:t>1/27/13</a:t>
+              <a:t>7/9/2026</a:t>
             </a:fld>
             <a:endParaRPr lang="en-US"/>
           </a:p>
@@ -917,10 +925,9 @@
           </a:lstStyle>
           <a:p>
             <a:r>
-              <a:rPr lang="en-US" smtClean="0"/>
+              <a:rPr lang="en-US"/>
               <a:t>Click to edit Master title style</a:t>
             </a:r>
-            <a:endParaRPr lang="en-US"/>
           </a:p>
         </p:txBody>
       </p:sp>
@@ -1037,7 +1044,7 @@
           <a:p>
             <a:pPr lvl="0"/>
             <a:r>
-              <a:rPr lang="en-US" smtClean="0"/>
+              <a:rPr lang="en-US"/>
               <a:t>Click to edit Master text styles</a:t>
             </a:r>
           </a:p>
@@ -1060,7 +1067,7 @@
           <a:p>
             <a:fld id="{5BCAD085-E8A6-8845-BD4E-CB4CCA059FC4}" type="datetimeFigureOut">
               <a:rPr lang="en-US" smtClean="0"/>
-              <a:t>1/27/13</a:t>
+              <a:t>7/9/2026</a:t>
             </a:fld>
             <a:endParaRPr lang="en-US"/>
           </a:p>
@@ -1154,10 +1161,9 @@
           <a:lstStyle/>
           <a:p>
             <a:r>
-              <a:rPr lang="en-US" smtClean="0"/>
+              <a:rPr lang="en-US"/>
               <a:t>Click to edit Master title style</a:t>
             </a:r>
-            <a:endParaRPr lang="en-US"/>
           </a:p>
         </p:txBody>
       </p:sp>
@@ -1211,38 +1217,37 @@
           <a:p>
             <a:pPr lvl="0"/>
             <a:r>
-              <a:rPr lang="en-US" smtClean="0"/>
+              <a:rPr lang="en-US"/>
               <a:t>Click to edit Master text styles</a:t>
             </a:r>
           </a:p>
           <a:p>
             <a:pPr lvl="1"/>
             <a:r>
-              <a:rPr lang="en-US" smtClean="0"/>
+              <a:rPr lang="en-US"/>
               <a:t>Second level</a:t>
             </a:r>
           </a:p>
           <a:p>
             <a:pPr lvl="2"/>
             <a:r>
-              <a:rPr lang="en-US" smtClean="0"/>
+              <a:rPr lang="en-US"/>
               <a:t>Third level</a:t>
             </a:r>
           </a:p>
           <a:p>
             <a:pPr lvl="3"/>
             <a:r>
-              <a:rPr lang="en-US" smtClean="0"/>
+              <a:rPr lang="en-US"/>
               <a:t>Fourth level</a:t>
             </a:r>
           </a:p>
           <a:p>
             <a:pPr lvl="4"/>
             <a:r>
-              <a:rPr lang="en-US" smtClean="0"/>
+              <a:rPr lang="en-US"/>
               <a:t>Fifth level</a:t>
             </a:r>
-            <a:endParaRPr lang="en-US"/>
           </a:p>
         </p:txBody>
       </p:sp>
@@ -1296,38 +1301,37 @@
           <a:p>
             <a:pPr lvl="0"/>
             <a:r>
-              <a:rPr lang="en-US" smtClean="0"/>
+              <a:rPr lang="en-US"/>
               <a:t>Click to edit Master text styles</a:t>
             </a:r>
           </a:p>
           <a:p>
             <a:pPr lvl="1"/>
             <a:r>
-              <a:rPr lang="en-US" smtClean="0"/>
+              <a:rPr lang="en-US"/>
               <a:t>Second level</a:t>
             </a:r>
           </a:p>
           <a:p>
             <a:pPr lvl="2"/>
             <a:r>
-              <a:rPr lang="en-US" smtClean="0"/>
+              <a:rPr lang="en-US"/>
               <a:t>Third level</a:t>
             </a:r>
           </a:p>
           <a:p>
             <a:pPr lvl="3"/>
             <a:r>
-              <a:rPr lang="en-US" smtClean="0"/>
+              <a:rPr lang="en-US"/>
               <a:t>Fourth level</a:t>
             </a:r>
           </a:p>
           <a:p>
             <a:pPr lvl="4"/>
             <a:r>
-              <a:rPr lang="en-US" smtClean="0"/>
+              <a:rPr lang="en-US"/>
               <a:t>Fifth level</a:t>
             </a:r>
-            <a:endParaRPr lang="en-US"/>
           </a:p>
         </p:txBody>
       </p:sp>
@@ -1348,7 +1352,7 @@
           <a:p>
             <a:fld id="{5BCAD085-E8A6-8845-BD4E-CB4CCA059FC4}" type="datetimeFigureOut">
               <a:rPr lang="en-US" smtClean="0"/>
-              <a:t>1/27/13</a:t>
+              <a:t>7/9/2026</a:t>
             </a:fld>
             <a:endParaRPr lang="en-US"/>
           </a:p>
@@ -1446,10 +1450,9 @@
           </a:lstStyle>
           <a:p>
             <a:r>
-              <a:rPr lang="en-US" smtClean="0"/>
+              <a:rPr lang="en-US"/>
               <a:t>Click to edit Master title style</a:t>
             </a:r>
-            <a:endParaRPr lang="en-US"/>
           </a:p>
         </p:txBody>
       </p:sp>
@@ -1512,7 +1515,7 @@
           <a:p>
             <a:pPr lvl="0"/>
             <a:r>
-              <a:rPr lang="en-US" smtClean="0"/>
+              <a:rPr lang="en-US"/>
               <a:t>Click to edit Master text styles</a:t>
             </a:r>
           </a:p>
@@ -1568,38 +1571,37 @@
           <a:p>
             <a:pPr lvl="0"/>
             <a:r>
-              <a:rPr lang="en-US" smtClean="0"/>
+              <a:rPr lang="en-US"/>
               <a:t>Click to edit Master text styles</a:t>
             </a:r>
           </a:p>
           <a:p>
             <a:pPr lvl="1"/>
             <a:r>
-              <a:rPr lang="en-US" smtClean="0"/>
+              <a:rPr lang="en-US"/>
               <a:t>Second level</a:t>
             </a:r>
           </a:p>
           <a:p>
             <a:pPr lvl="2"/>
             <a:r>
-              <a:rPr lang="en-US" smtClean="0"/>
+              <a:rPr lang="en-US"/>
               <a:t>Third level</a:t>
             </a:r>
           </a:p>
           <a:p>
             <a:pPr lvl="3"/>
             <a:r>
-              <a:rPr lang="en-US" smtClean="0"/>
+              <a:rPr lang="en-US"/>
               <a:t>Fourth level</a:t>
             </a:r>
           </a:p>
           <a:p>
             <a:pPr lvl="4"/>
             <a:r>
-              <a:rPr lang="en-US" smtClean="0"/>
+              <a:rPr lang="en-US"/>
               <a:t>Fifth level</a:t>
             </a:r>
-            <a:endParaRPr lang="en-US"/>
           </a:p>
         </p:txBody>
       </p:sp>
@@ -1662,7 +1664,7 @@
           <a:p>
             <a:pPr lvl="0"/>
             <a:r>
-              <a:rPr lang="en-US" smtClean="0"/>
+              <a:rPr lang="en-US"/>
               <a:t>Click to edit Master text styles</a:t>
             </a:r>
           </a:p>
@@ -1718,38 +1720,37 @@
           <a:p>
             <a:pPr lvl="0"/>
             <a:r>
-              <a:rPr lang="en-US" smtClean="0"/>
+              <a:rPr lang="en-US"/>
               <a:t>Click to edit Master text styles</a:t>
             </a:r>
           </a:p>
           <a:p>
             <a:pPr lvl="1"/>
             <a:r>
-              <a:rPr lang="en-US" smtClean="0"/>
+              <a:rPr lang="en-US"/>
               <a:t>Second level</a:t>
             </a:r>
           </a:p>
           <a:p>
             <a:pPr lvl="2"/>
             <a:r>
-              <a:rPr lang="en-US" smtClean="0"/>
+              <a:rPr lang="en-US"/>
               <a:t>Third level</a:t>
             </a:r>
           </a:p>
           <a:p>
             <a:pPr lvl="3"/>
             <a:r>
-              <a:rPr lang="en-US" smtClean="0"/>
+              <a:rPr lang="en-US"/>
               <a:t>Fourth level</a:t>
             </a:r>
           </a:p>
           <a:p>
             <a:pPr lvl="4"/>
             <a:r>
-              <a:rPr lang="en-US" smtClean="0"/>
+              <a:rPr lang="en-US"/>
               <a:t>Fifth level</a:t>
             </a:r>
-            <a:endParaRPr lang="en-US"/>
           </a:p>
         </p:txBody>
       </p:sp>
@@ -1770,7 +1771,7 @@
           <a:p>
             <a:fld id="{5BCAD085-E8A6-8845-BD4E-CB4CCA059FC4}" type="datetimeFigureOut">
               <a:rPr lang="en-US" smtClean="0"/>
-              <a:t>1/27/13</a:t>
+              <a:t>7/9/2026</a:t>
             </a:fld>
             <a:endParaRPr lang="en-US"/>
           </a:p>
@@ -1864,10 +1865,9 @@
           <a:lstStyle/>
           <a:p>
             <a:r>
-              <a:rPr lang="en-US" smtClean="0"/>
+              <a:rPr lang="en-US"/>
               <a:t>Click to edit Master title style</a:t>
             </a:r>
-            <a:endParaRPr lang="en-US"/>
           </a:p>
         </p:txBody>
       </p:sp>
@@ -1888,7 +1888,7 @@
           <a:p>
             <a:fld id="{5BCAD085-E8A6-8845-BD4E-CB4CCA059FC4}" type="datetimeFigureOut">
               <a:rPr lang="en-US" smtClean="0"/>
-              <a:t>1/27/13</a:t>
+              <a:t>7/9/2026</a:t>
             </a:fld>
             <a:endParaRPr lang="en-US"/>
           </a:p>
@@ -1983,7 +1983,7 @@
           <a:p>
             <a:fld id="{5BCAD085-E8A6-8845-BD4E-CB4CCA059FC4}" type="datetimeFigureOut">
               <a:rPr lang="en-US" smtClean="0"/>
-              <a:t>1/27/13</a:t>
+              <a:t>7/9/2026</a:t>
             </a:fld>
             <a:endParaRPr lang="en-US"/>
           </a:p>
@@ -2086,10 +2086,9 @@
           </a:lstStyle>
           <a:p>
             <a:r>
-              <a:rPr lang="en-US" smtClean="0"/>
+              <a:rPr lang="en-US"/>
               <a:t>Click to edit Master title style</a:t>
             </a:r>
-            <a:endParaRPr lang="en-US"/>
           </a:p>
         </p:txBody>
       </p:sp>
@@ -2143,38 +2142,37 @@
           <a:p>
             <a:pPr lvl="0"/>
             <a:r>
-              <a:rPr lang="en-US" smtClean="0"/>
+              <a:rPr lang="en-US"/>
               <a:t>Click to edit Master text styles</a:t>
             </a:r>
           </a:p>
           <a:p>
             <a:pPr lvl="1"/>
             <a:r>
-              <a:rPr lang="en-US" smtClean="0"/>
+              <a:rPr lang="en-US"/>
               <a:t>Second level</a:t>
             </a:r>
           </a:p>
           <a:p>
             <a:pPr lvl="2"/>
             <a:r>
-              <a:rPr lang="en-US" smtClean="0"/>
+              <a:rPr lang="en-US"/>
               <a:t>Third level</a:t>
             </a:r>
           </a:p>
           <a:p>
             <a:pPr lvl="3"/>
             <a:r>
-              <a:rPr lang="en-US" smtClean="0"/>
+              <a:rPr lang="en-US"/>
               <a:t>Fourth level</a:t>
             </a:r>
           </a:p>
           <a:p>
             <a:pPr lvl="4"/>
             <a:r>
-              <a:rPr lang="en-US" smtClean="0"/>
+              <a:rPr lang="en-US"/>
               <a:t>Fifth level</a:t>
             </a:r>
-            <a:endParaRPr lang="en-US"/>
           </a:p>
         </p:txBody>
       </p:sp>
@@ -2237,7 +2235,7 @@
           <a:p>
             <a:pPr lvl="0"/>
             <a:r>
-              <a:rPr lang="en-US" smtClean="0"/>
+              <a:rPr lang="en-US"/>
               <a:t>Click to edit Master text styles</a:t>
             </a:r>
           </a:p>
@@ -2260,7 +2258,7 @@
           <a:p>
             <a:fld id="{5BCAD085-E8A6-8845-BD4E-CB4CCA059FC4}" type="datetimeFigureOut">
               <a:rPr lang="en-US" smtClean="0"/>
-              <a:t>1/27/13</a:t>
+              <a:t>7/9/2026</a:t>
             </a:fld>
             <a:endParaRPr lang="en-US"/>
           </a:p>
@@ -2363,10 +2361,9 @@
           </a:lstStyle>
           <a:p>
             <a:r>
-              <a:rPr lang="en-US" smtClean="0"/>
+              <a:rPr lang="en-US"/>
               <a:t>Click to edit Master title style</a:t>
             </a:r>
-            <a:endParaRPr lang="en-US"/>
           </a:p>
         </p:txBody>
       </p:sp>
@@ -2490,7 +2487,7 @@
           <a:p>
             <a:pPr lvl="0"/>
             <a:r>
-              <a:rPr lang="en-US" smtClean="0"/>
+              <a:rPr lang="en-US"/>
               <a:t>Click to edit Master text styles</a:t>
             </a:r>
           </a:p>
@@ -2513,7 +2510,7 @@
           <a:p>
             <a:fld id="{5BCAD085-E8A6-8845-BD4E-CB4CCA059FC4}" type="datetimeFigureOut">
               <a:rPr lang="en-US" smtClean="0"/>
-              <a:t>1/27/13</a:t>
+              <a:t>7/9/2026</a:t>
             </a:fld>
             <a:endParaRPr lang="en-US"/>
           </a:p>
@@ -2622,10 +2619,9 @@
           <a:lstStyle/>
           <a:p>
             <a:r>
-              <a:rPr lang="en-US" smtClean="0"/>
+              <a:rPr lang="en-US"/>
               <a:t>Click to edit Master title style</a:t>
             </a:r>
-            <a:endParaRPr lang="en-US"/>
           </a:p>
         </p:txBody>
       </p:sp>
@@ -2656,38 +2652,37 @@
           <a:p>
             <a:pPr lvl="0"/>
             <a:r>
-              <a:rPr lang="en-US" smtClean="0"/>
+              <a:rPr lang="en-US"/>
               <a:t>Click to edit Master text styles</a:t>
             </a:r>
           </a:p>
           <a:p>
             <a:pPr lvl="1"/>
             <a:r>
-              <a:rPr lang="en-US" smtClean="0"/>
+              <a:rPr lang="en-US"/>
               <a:t>Second level</a:t>
             </a:r>
           </a:p>
           <a:p>
             <a:pPr lvl="2"/>
             <a:r>
-              <a:rPr lang="en-US" smtClean="0"/>
+              <a:rPr lang="en-US"/>
               <a:t>Third level</a:t>
             </a:r>
           </a:p>
           <a:p>
             <a:pPr lvl="3"/>
             <a:r>
-              <a:rPr lang="en-US" smtClean="0"/>
+              <a:rPr lang="en-US"/>
               <a:t>Fourth level</a:t>
             </a:r>
           </a:p>
           <a:p>
             <a:pPr lvl="4"/>
             <a:r>
-              <a:rPr lang="en-US" smtClean="0"/>
+              <a:rPr lang="en-US"/>
               <a:t>Fifth level</a:t>
             </a:r>
-            <a:endParaRPr lang="en-US"/>
           </a:p>
         </p:txBody>
       </p:sp>
@@ -2726,7 +2721,7 @@
           <a:p>
             <a:fld id="{5BCAD085-E8A6-8845-BD4E-CB4CCA059FC4}" type="datetimeFigureOut">
               <a:rPr lang="en-US" smtClean="0"/>
-              <a:t>1/27/13</a:t>
+              <a:t>7/9/2026</a:t>
             </a:fld>
             <a:endParaRPr lang="en-US"/>
           </a:p>
@@ -3085,7 +3080,7 @@
 </file>
 
 <file path=ppt/slides/slide1.xml><?xml version="1.0" encoding="utf-8"?>
-<p:sld xmlns:a="http://schemas.openxmlformats.org/drawingml/2006/main" xmlns:p="http://schemas.openxmlformats.org/presentationml/2006/main" xmlns:r="http://schemas.openxmlformats.org/officeDocument/2006/relationships">
+<p:sld xmlns:a="http://schemas.openxmlformats.org/drawingml/2006/main" xmlns:r="http://schemas.openxmlformats.org/officeDocument/2006/relationships" xmlns:p="http://schemas.openxmlformats.org/presentationml/2006/main">
   <p:cSld>
     <p:bg>
       <p:bgPr>
@@ -3101,7 +3096,14 @@
         <p:cNvGrpSpPr/>
         <p:nvPr/>
       </p:nvGrpSpPr>
-      <p:grpSpPr/>
+      <p:grpSpPr>
+        <a:xfrm>
+          <a:off x="0" y="0"/>
+          <a:ext cx="0" cy="0"/>
+          <a:chOff x="0" y="0"/>
+          <a:chExt cx="0" cy="0"/>
+        </a:xfrm>
+      </p:grpSpPr>
       <p:sp>
         <p:nvSpPr>
           <p:cNvPr id="2" name="TextBox 1"/>
@@ -3110,8 +3112,8 @@
         </p:nvSpPr>
         <p:spPr>
           <a:xfrm>
-            <a:off x="685800" y="731520"/>
-            <a:ext cx="10817352" cy="2011680"/>
+            <a:off x="538316" y="2357776"/>
+            <a:ext cx="5872316" cy="1969770"/>
           </a:xfrm>
           <a:prstGeom prst="rect">
             <a:avLst/>
@@ -3132,7 +3134,12 @@
               </a:defRPr>
             </a:pPr>
             <a:r>
-              <a:t>AttriSense AI</a:t>
+              <a:rPr dirty="0" err="1"/>
+              <a:t>AttriSense</a:t>
+            </a:r>
+            <a:r>
+              <a:rPr dirty="0"/>
+              <a:t> AI</a:t>
             </a:r>
           </a:p>
           <a:p>
@@ -3144,8 +3151,24 @@
               </a:defRPr>
             </a:pPr>
             <a:r>
-              <a:t>Predictive Attrition Intelligence Platform</a:t>
-            </a:r>
+              <a:rPr dirty="0"/>
+              <a:t>Predictive Attrition</a:t>
+            </a:r>
+            <a:endParaRPr lang="en-US" dirty="0"/>
+          </a:p>
+          <a:p>
+            <a:pPr algn="l">
+              <a:defRPr sz="2600">
+                <a:solidFill>
+                  <a:srgbClr val="F8FAFC"/>
+                </a:solidFill>
+              </a:defRPr>
+            </a:pPr>
+            <a:r>
+              <a:rPr dirty="0"/>
+              <a:t>Intelligence Platform</a:t>
+            </a:r>
+            <a:endParaRPr lang="en-IN" dirty="0"/>
           </a:p>
           <a:p>
             <a:pPr algn="l">
@@ -3156,6 +3179,7 @@
               </a:defRPr>
             </a:pPr>
             <a:r>
+              <a:rPr lang="en-IN" dirty="0"/>
               <a:t>LTTS Global Hackathon 2026 | Jury Presentation</a:t>
             </a:r>
           </a:p>
@@ -3163,7 +3187,13 @@
       </p:sp>
       <p:pic>
         <p:nvPicPr>
-          <p:cNvPr id="3" name="Picture 2" descr="submission_cover_banner_1783602439772.png"/>
+          <p:cNvPr id="5" name="Picture 4">
+            <a:extLst>
+              <a:ext uri="{FF2B5EF4-FFF2-40B4-BE49-F238E27FC236}">
+                <a16:creationId xmlns:a16="http://schemas.microsoft.com/office/drawing/2014/main" id="{E7FD334B-CD7E-1C21-2E04-86450F0CFDDE}"/>
+              </a:ext>
+            </a:extLst>
+          </p:cNvPr>
           <p:cNvPicPr>
             <a:picLocks noChangeAspect="1"/>
           </p:cNvPicPr>
@@ -3177,8 +3207,8 @@
         </p:blipFill>
         <p:spPr>
           <a:xfrm>
-            <a:off x="685800" y="2926080"/>
-            <a:ext cx="10817352" cy="3200400"/>
+            <a:off x="5675672" y="250870"/>
+            <a:ext cx="6356260" cy="6356260"/>
           </a:xfrm>
           <a:prstGeom prst="rect">
             <a:avLst/>
@@ -3194,7 +3224,7 @@
 </file>
 
 <file path=ppt/slides/slide2.xml><?xml version="1.0" encoding="utf-8"?>
-<p:sld xmlns:a="http://schemas.openxmlformats.org/drawingml/2006/main" xmlns:p="http://schemas.openxmlformats.org/presentationml/2006/main" xmlns:r="http://schemas.openxmlformats.org/officeDocument/2006/relationships">
+<p:sld xmlns:a="http://schemas.openxmlformats.org/drawingml/2006/main" xmlns:r="http://schemas.openxmlformats.org/officeDocument/2006/relationships" xmlns:p="http://schemas.openxmlformats.org/presentationml/2006/main">
   <p:cSld>
     <p:bg>
       <p:bgPr>
@@ -3210,7 +3240,14 @@
         <p:cNvGrpSpPr/>
         <p:nvPr/>
       </p:nvGrpSpPr>
-      <p:grpSpPr/>
+      <p:grpSpPr>
+        <a:xfrm>
+          <a:off x="0" y="0"/>
+          <a:ext cx="0" cy="0"/>
+          <a:chOff x="0" y="0"/>
+          <a:chExt cx="0" cy="0"/>
+        </a:xfrm>
+      </p:grpSpPr>
       <p:sp>
         <p:nvSpPr>
           <p:cNvPr id="2" name="TextBox 1"/>
@@ -3219,8 +3256,8 @@
         </p:nvSpPr>
         <p:spPr>
           <a:xfrm>
-            <a:off x="685800" y="365760"/>
-            <a:ext cx="10789920" cy="914400"/>
+            <a:off x="685799" y="365760"/>
+            <a:ext cx="11240729" cy="830997"/>
           </a:xfrm>
           <a:prstGeom prst="rect">
             <a:avLst/>
@@ -3241,6 +3278,7 @@
               </a:defRPr>
             </a:pPr>
             <a:r>
+              <a:rPr dirty="0"/>
               <a:t>Multi-Agent System Architecture</a:t>
             </a:r>
           </a:p>
@@ -3253,6 +3291,7 @@
               </a:defRPr>
             </a:pPr>
             <a:r>
+              <a:rPr dirty="0"/>
               <a:t>Google ADK 2.4.0 + Specialist Agent Orchestration</a:t>
             </a:r>
           </a:p>
@@ -3279,7 +3318,9 @@
             <a:spAutoFit/>
           </a:bodyPr>
           <a:lstStyle/>
-          <a:p/>
+          <a:p>
+            <a:endParaRPr dirty="0"/>
+          </a:p>
           <a:p>
             <a:pPr>
               <a:defRPr sz="1600" b="1">
@@ -3289,6 +3330,7 @@
               </a:defRPr>
             </a:pPr>
             <a:r>
+              <a:rPr dirty="0"/>
               <a:t>• Step 1: Telemetry Sensor Network</a:t>
             </a:r>
           </a:p>
@@ -3304,7 +3346,16 @@
               </a:defRPr>
             </a:pPr>
             <a:r>
-              <a:t>  Aggregates 15 continuous behavioral and work-life telemetry signals via mcp_server.</a:t>
+              <a:rPr dirty="0"/>
+              <a:t>  Aggregates 15 continuous behavioral and work-life telemetry signals via </a:t>
+            </a:r>
+            <a:r>
+              <a:rPr dirty="0" err="1"/>
+              <a:t>mcp_server</a:t>
+            </a:r>
+            <a:r>
+              <a:rPr dirty="0"/>
+              <a:t>.</a:t>
             </a:r>
           </a:p>
           <a:p>
@@ -3316,6 +3367,7 @@
               </a:defRPr>
             </a:pPr>
             <a:r>
+              <a:rPr dirty="0"/>
               <a:t>• Step 2: Sentiment NLP Analyzer</a:t>
             </a:r>
           </a:p>
@@ -3331,6 +3383,7 @@
               </a:defRPr>
             </a:pPr>
             <a:r>
+              <a:rPr dirty="0"/>
               <a:t>  Runs real-time sentiment extraction &amp; disengagement theme detection on employee voice data.</a:t>
             </a:r>
           </a:p>
@@ -3343,6 +3396,7 @@
               </a:defRPr>
             </a:pPr>
             <a:r>
+              <a:rPr dirty="0"/>
               <a:t>• Step 3: Risk Score Calculator</a:t>
             </a:r>
           </a:p>
@@ -3358,6 +3412,7 @@
               </a:defRPr>
             </a:pPr>
             <a:r>
+              <a:rPr dirty="0"/>
               <a:t>  Processes weights to compile a real-time risk index (0-100%) and categorizes flight risk.</a:t>
             </a:r>
           </a:p>
@@ -3370,6 +3425,7 @@
               </a:defRPr>
             </a:pPr>
             <a:r>
+              <a:rPr dirty="0"/>
               <a:t>• Step 4: AI Retention Playbook Advisor</a:t>
             </a:r>
           </a:p>
@@ -3385,6 +3441,7 @@
               </a:defRPr>
             </a:pPr>
             <a:r>
+              <a:rPr dirty="0"/>
               <a:t>  Maps risk drivers to corporate mitigation playbooks to synthesize direct action steps.</a:t>
             </a:r>
           </a:p>
@@ -3397,6 +3454,7 @@
               </a:defRPr>
             </a:pPr>
             <a:r>
+              <a:rPr dirty="0"/>
               <a:t>• Step 5: Security &amp; Privacy Gateway</a:t>
             </a:r>
           </a:p>
@@ -3412,6 +3470,7 @@
               </a:defRPr>
             </a:pPr>
             <a:r>
+              <a:rPr dirty="0"/>
               <a:t>  Enforces PII redaction, prompt injection defense, and role-based view/edit permissions.</a:t>
             </a:r>
           </a:p>
@@ -3433,8 +3492,8 @@
         </p:blipFill>
         <p:spPr>
           <a:xfrm>
-            <a:off x="6217920" y="1645920"/>
-            <a:ext cx="5303520" cy="4389120"/>
+            <a:off x="5989320" y="1525966"/>
+            <a:ext cx="6080515" cy="5032150"/>
           </a:xfrm>
           <a:prstGeom prst="rect">
             <a:avLst/>
@@ -3450,7 +3509,7 @@
 </file>
 
 <file path=ppt/slides/slide3.xml><?xml version="1.0" encoding="utf-8"?>
-<p:sld xmlns:a="http://schemas.openxmlformats.org/drawingml/2006/main" xmlns:p="http://schemas.openxmlformats.org/presentationml/2006/main" xmlns:r="http://schemas.openxmlformats.org/officeDocument/2006/relationships">
+<p:sld xmlns:a="http://schemas.openxmlformats.org/drawingml/2006/main" xmlns:r="http://schemas.openxmlformats.org/officeDocument/2006/relationships" xmlns:p="http://schemas.openxmlformats.org/presentationml/2006/main">
   <p:cSld>
     <p:bg>
       <p:bgPr>
@@ -3466,7 +3525,14 @@
         <p:cNvGrpSpPr/>
         <p:nvPr/>
       </p:nvGrpSpPr>
-      <p:grpSpPr/>
+      <p:grpSpPr>
+        <a:xfrm>
+          <a:off x="0" y="0"/>
+          <a:ext cx="0" cy="0"/>
+          <a:chOff x="0" y="0"/>
+          <a:chExt cx="0" cy="0"/>
+        </a:xfrm>
+      </p:grpSpPr>
       <p:sp>
         <p:nvSpPr>
           <p:cNvPr id="2" name="TextBox 1"/>
@@ -3535,7 +3601,9 @@
             <a:spAutoFit/>
           </a:bodyPr>
           <a:lstStyle/>
-          <a:p/>
+          <a:p>
+            <a:endParaRPr/>
+          </a:p>
           <a:p>
             <a:pPr>
               <a:defRPr sz="1400" b="1">
@@ -3748,7 +3816,9 @@
             <a:spAutoFit/>
           </a:bodyPr>
           <a:lstStyle/>
-          <a:p/>
+          <a:p>
+            <a:endParaRPr/>
+          </a:p>
           <a:p>
             <a:pPr>
               <a:defRPr sz="1400" b="1">
@@ -3976,7 +4046,7 @@
 </file>
 
 <file path=ppt/slides/slide4.xml><?xml version="1.0" encoding="utf-8"?>
-<p:sld xmlns:a="http://schemas.openxmlformats.org/drawingml/2006/main" xmlns:p="http://schemas.openxmlformats.org/presentationml/2006/main" xmlns:r="http://schemas.openxmlformats.org/officeDocument/2006/relationships">
+<p:sld xmlns:a="http://schemas.openxmlformats.org/drawingml/2006/main" xmlns:r="http://schemas.openxmlformats.org/officeDocument/2006/relationships" xmlns:p="http://schemas.openxmlformats.org/presentationml/2006/main">
   <p:cSld>
     <p:bg>
       <p:bgPr>
@@ -3992,7 +4062,14 @@
         <p:cNvGrpSpPr/>
         <p:nvPr/>
       </p:nvGrpSpPr>
-      <p:grpSpPr/>
+      <p:grpSpPr>
+        <a:xfrm>
+          <a:off x="0" y="0"/>
+          <a:ext cx="0" cy="0"/>
+          <a:chOff x="0" y="0"/>
+          <a:chExt cx="0" cy="0"/>
+        </a:xfrm>
+      </p:grpSpPr>
       <p:sp>
         <p:nvSpPr>
           <p:cNvPr id="2" name="TextBox 1"/>
@@ -4061,7 +4138,9 @@
             <a:spAutoFit/>
           </a:bodyPr>
           <a:lstStyle/>
-          <a:p/>
+          <a:p>
+            <a:endParaRPr dirty="0"/>
+          </a:p>
           <a:p>
             <a:pPr>
               <a:spcAft>
@@ -4074,6 +4153,7 @@
               </a:defRPr>
             </a:pPr>
             <a:r>
+              <a:rPr dirty="0"/>
               <a:t>Step 2: Sentiment NLP Processing</a:t>
             </a:r>
           </a:p>
@@ -4082,17 +4162,15 @@
               <a:spcAft>
                 <a:spcPts val="800"/>
               </a:spcAft>
-              <a:defRPr b="1" sz="1200">
+              <a:defRPr sz="1200" b="1">
                 <a:solidFill>
                   <a:srgbClr val="F8FAFC"/>
                 </a:solidFill>
               </a:defRPr>
             </a:pPr>
             <a:r>
-              <a:t>• Real-Time NLP Parsing: </a:t>
-            </a:r>
-            <a:r>
-              <a:t>Evaluates employee written feedback, pulse surveys, and ticket updates.</a:t>
+              <a:rPr dirty="0"/>
+              <a:t>• Real-Time NLP Parsing: Evaluates employee written feedback, pulse surveys, and ticket updates.</a:t>
             </a:r>
           </a:p>
           <a:p>
@@ -4100,17 +4178,15 @@
               <a:spcAft>
                 <a:spcPts val="800"/>
               </a:spcAft>
-              <a:defRPr b="1" sz="1200">
+              <a:defRPr sz="1200" b="1">
                 <a:solidFill>
                   <a:srgbClr val="F8FAFC"/>
                 </a:solidFill>
               </a:defRPr>
             </a:pPr>
             <a:r>
-              <a:t>• Numeric Mood Indexing: </a:t>
-            </a:r>
-            <a:r>
-              <a:t>Converts qualitative feedback into a scalar range from -1.0 (Highly Disengaged) to +1.0 (Enthusiastic).</a:t>
+              <a:rPr dirty="0"/>
+              <a:t>• Numeric Mood Indexing: Converts qualitative feedback into a scalar range from -1.0 (Highly Disengaged) to +1.0 (Enthusiastic).</a:t>
             </a:r>
           </a:p>
           <a:p>
@@ -4118,17 +4194,39 @@
               <a:spcAft>
                 <a:spcPts val="800"/>
               </a:spcAft>
-              <a:defRPr b="1" sz="1200">
+              <a:defRPr sz="1200" b="1">
                 <a:solidFill>
                   <a:srgbClr val="F8FAFC"/>
                 </a:solidFill>
               </a:defRPr>
             </a:pPr>
             <a:r>
-              <a:t>• Core Theme Extraction: </a:t>
-            </a:r>
-            <a:r>
-              <a:t>Identifies specific pain points such as 'burnout', 'career_stagnation', 'workload_pressure', or 'manager_friction'.</a:t>
+              <a:rPr dirty="0"/>
+              <a:t>• Core Theme Extraction: Identifies specific pain points such as 'burnout', '</a:t>
+            </a:r>
+            <a:r>
+              <a:rPr dirty="0" err="1"/>
+              <a:t>career_stagnation</a:t>
+            </a:r>
+            <a:r>
+              <a:rPr dirty="0"/>
+              <a:t>', '</a:t>
+            </a:r>
+            <a:r>
+              <a:rPr dirty="0" err="1"/>
+              <a:t>workload_pressure</a:t>
+            </a:r>
+            <a:r>
+              <a:rPr dirty="0"/>
+              <a:t>', or '</a:t>
+            </a:r>
+            <a:r>
+              <a:rPr dirty="0" err="1"/>
+              <a:t>manager_friction</a:t>
+            </a:r>
+            <a:r>
+              <a:rPr dirty="0"/>
+              <a:t>'.</a:t>
             </a:r>
           </a:p>
           <a:p>
@@ -4136,17 +4234,15 @@
               <a:spcAft>
                 <a:spcPts val="800"/>
               </a:spcAft>
-              <a:defRPr b="1" sz="1200">
+              <a:defRPr sz="1200" b="1">
                 <a:solidFill>
                   <a:srgbClr val="F8FAFC"/>
                 </a:solidFill>
               </a:defRPr>
             </a:pPr>
             <a:r>
-              <a:t>• Contextual Synthesis: </a:t>
-            </a:r>
-            <a:r>
-              <a:t>Enables the Orchestrator to understand the human story behind the numbers.</a:t>
+              <a:rPr dirty="0"/>
+              <a:t>• Contextual Synthesis: Enables the Orchestrator to understand the human story behind the numbers.</a:t>
             </a:r>
           </a:p>
         </p:txBody>
@@ -4172,7 +4268,9 @@
             <a:spAutoFit/>
           </a:bodyPr>
           <a:lstStyle/>
-          <a:p/>
+          <a:p>
+            <a:endParaRPr dirty="0"/>
+          </a:p>
           <a:p>
             <a:pPr>
               <a:spcAft>
@@ -4185,6 +4283,7 @@
               </a:defRPr>
             </a:pPr>
             <a:r>
+              <a:rPr dirty="0"/>
               <a:t>Step 3: Risk Level Classification</a:t>
             </a:r>
           </a:p>
@@ -4197,6 +4296,7 @@
               </a:defRPr>
             </a:pPr>
             <a:r>
+              <a:rPr dirty="0"/>
               <a:t>🔴 CRITICAL (Score &gt;= 80%)</a:t>
             </a:r>
           </a:p>
@@ -4212,6 +4312,7 @@
               </a:defRPr>
             </a:pPr>
             <a:r>
+              <a:rPr dirty="0"/>
               <a:t>Action Window: &lt; 3 months. Requires immediate senior HR intervention and salary/overtime audit.</a:t>
             </a:r>
           </a:p>
@@ -4224,6 +4325,7 @@
               </a:defRPr>
             </a:pPr>
             <a:r>
+              <a:rPr dirty="0"/>
               <a:t>🟠 HIGH (Score 60% - 79%)</a:t>
             </a:r>
           </a:p>
@@ -4239,6 +4341,7 @@
               </a:defRPr>
             </a:pPr>
             <a:r>
+              <a:rPr dirty="0"/>
               <a:t>Action Window: &lt; 6 months. Triggers automated manager check-ins, skip-levels, and workload cap.</a:t>
             </a:r>
           </a:p>
@@ -4251,6 +4354,7 @@
               </a:defRPr>
             </a:pPr>
             <a:r>
+              <a:rPr dirty="0"/>
               <a:t>🟡 MODERATE (Score 35% - 59%)</a:t>
             </a:r>
           </a:p>
@@ -4266,6 +4370,7 @@
               </a:defRPr>
             </a:pPr>
             <a:r>
+              <a:rPr dirty="0"/>
               <a:t>Action Window: &lt; 12 months. Requires quarterly reviews, skill alignment, and training incentives.</a:t>
             </a:r>
           </a:p>
@@ -4278,6 +4383,7 @@
               </a:defRPr>
             </a:pPr>
             <a:r>
+              <a:rPr dirty="0"/>
               <a:t>🟢 LOW (Score &lt; 35%)</a:t>
             </a:r>
           </a:p>
@@ -4293,6 +4399,7 @@
               </a:defRPr>
             </a:pPr>
             <a:r>
+              <a:rPr dirty="0"/>
               <a:t>Stable tier. Monitored on a standard bi-annual cycle.</a:t>
             </a:r>
           </a:p>
@@ -4307,7 +4414,7 @@
 </file>
 
 <file path=ppt/slides/slide5.xml><?xml version="1.0" encoding="utf-8"?>
-<p:sld xmlns:a="http://schemas.openxmlformats.org/drawingml/2006/main" xmlns:p="http://schemas.openxmlformats.org/presentationml/2006/main" xmlns:r="http://schemas.openxmlformats.org/officeDocument/2006/relationships">
+<p:sld xmlns:a="http://schemas.openxmlformats.org/drawingml/2006/main" xmlns:r="http://schemas.openxmlformats.org/officeDocument/2006/relationships" xmlns:p="http://schemas.openxmlformats.org/presentationml/2006/main">
   <p:cSld>
     <p:bg>
       <p:bgPr>
@@ -4323,7 +4430,14 @@
         <p:cNvGrpSpPr/>
         <p:nvPr/>
       </p:nvGrpSpPr>
-      <p:grpSpPr/>
+      <p:grpSpPr>
+        <a:xfrm>
+          <a:off x="0" y="0"/>
+          <a:ext cx="0" cy="0"/>
+          <a:chOff x="0" y="0"/>
+          <a:chExt cx="0" cy="0"/>
+        </a:xfrm>
+      </p:grpSpPr>
       <p:sp>
         <p:nvSpPr>
           <p:cNvPr id="2" name="TextBox 1"/>
@@ -4392,7 +4506,9 @@
             <a:spAutoFit/>
           </a:bodyPr>
           <a:lstStyle/>
-          <a:p/>
+          <a:p>
+            <a:endParaRPr/>
+          </a:p>
           <a:p>
             <a:pPr>
               <a:spcAft>
@@ -4413,17 +4529,14 @@
               <a:spcAft>
                 <a:spcPts val="800"/>
               </a:spcAft>
-              <a:defRPr b="1" sz="1200">
+              <a:defRPr sz="1200" b="1">
                 <a:solidFill>
                   <a:srgbClr val="F8FAFC"/>
                 </a:solidFill>
               </a:defRPr>
             </a:pPr>
             <a:r>
-              <a:t>• Overtime &amp; Hours Playbook: </a:t>
-            </a:r>
-            <a:r>
-              <a:t>Mitigates burnout by enforcing strict weekend caps, shifting loads, or introducing flexi-time.</a:t>
+              <a:t>• Overtime &amp; Hours Playbook: Mitigates burnout by enforcing strict weekend caps, shifting loads, or introducing flexi-time.</a:t>
             </a:r>
           </a:p>
           <a:p>
@@ -4431,17 +4544,14 @@
               <a:spcAft>
                 <a:spcPts val="800"/>
               </a:spcAft>
-              <a:defRPr b="1" sz="1200">
+              <a:defRPr sz="1200" b="1">
                 <a:solidFill>
                   <a:srgbClr val="F8FAFC"/>
                 </a:solidFill>
               </a:defRPr>
             </a:pPr>
             <a:r>
-              <a:t>• Compensation Review Playbook: </a:t>
-            </a:r>
-            <a:r>
-              <a:t>Initiates salary percentile benchmarks vs. market averages and prepares business case for increases.</a:t>
+              <a:t>• Compensation Review Playbook: Initiates salary percentile benchmarks vs. market averages and prepares business case for increases.</a:t>
             </a:r>
           </a:p>
           <a:p>
@@ -4449,17 +4559,14 @@
               <a:spcAft>
                 <a:spcPts val="800"/>
               </a:spcAft>
-              <a:defRPr b="1" sz="1200">
+              <a:defRPr sz="1200" b="1">
                 <a:solidFill>
                   <a:srgbClr val="F8FAFC"/>
                 </a:solidFill>
               </a:defRPr>
             </a:pPr>
             <a:r>
-              <a:t>• Career Stagnation Playbook: </a:t>
-            </a:r>
-            <a:r>
-              <a:t>Fast-tracks performance appraisals, assigns mentors, and allocates training budgets.</a:t>
+              <a:t>• Career Stagnation Playbook: Fast-tracks performance appraisals, assigns mentors, and allocates training budgets.</a:t>
             </a:r>
           </a:p>
           <a:p>
@@ -4467,17 +4574,14 @@
               <a:spcAft>
                 <a:spcPts val="800"/>
               </a:spcAft>
-              <a:defRPr b="1" sz="1200">
+              <a:defRPr sz="1200" b="1">
                 <a:solidFill>
                   <a:srgbClr val="F8FAFC"/>
                 </a:solidFill>
               </a:defRPr>
             </a:pPr>
             <a:r>
-              <a:t>• Manager Alignment Playbook: </a:t>
-            </a:r>
-            <a:r>
-              <a:t>Initiates skip-level check-ins and offers communication support to the team lead.</a:t>
+              <a:t>• Manager Alignment Playbook: Initiates skip-level check-ins and offers communication support to the team lead.</a:t>
             </a:r>
           </a:p>
         </p:txBody>
@@ -4503,7 +4607,9 @@
             <a:spAutoFit/>
           </a:bodyPr>
           <a:lstStyle/>
-          <a:p/>
+          <a:p>
+            <a:endParaRPr/>
+          </a:p>
           <a:p>
             <a:pPr>
               <a:spcAft>
@@ -4521,7 +4627,7 @@
           </a:p>
           <a:p>
             <a:pPr>
-              <a:defRPr b="1" sz="1400">
+              <a:defRPr sz="1400" b="1">
                 <a:solidFill>
                   <a:srgbClr val="06B6D4"/>
                 </a:solidFill>
@@ -4548,7 +4654,7 @@
           </a:p>
           <a:p>
             <a:pPr>
-              <a:defRPr b="1" sz="1400">
+              <a:defRPr sz="1400" b="1">
                 <a:solidFill>
                   <a:srgbClr val="06B6D4"/>
                 </a:solidFill>
@@ -4575,7 +4681,7 @@
           </a:p>
           <a:p>
             <a:pPr>
-              <a:defRPr b="1" sz="1400">
+              <a:defRPr sz="1400" b="1">
                 <a:solidFill>
                   <a:srgbClr val="06B6D4"/>
                 </a:solidFill>
@@ -4627,7 +4733,7 @@
 </file>
 
 <file path=ppt/slides/slide6.xml><?xml version="1.0" encoding="utf-8"?>
-<p:sld xmlns:a="http://schemas.openxmlformats.org/drawingml/2006/main" xmlns:p="http://schemas.openxmlformats.org/presentationml/2006/main" xmlns:r="http://schemas.openxmlformats.org/officeDocument/2006/relationships">
+<p:sld xmlns:a="http://schemas.openxmlformats.org/drawingml/2006/main" xmlns:r="http://schemas.openxmlformats.org/officeDocument/2006/relationships" xmlns:p="http://schemas.openxmlformats.org/presentationml/2006/main">
   <p:cSld>
     <p:bg>
       <p:bgPr>
@@ -4643,7 +4749,14 @@
         <p:cNvGrpSpPr/>
         <p:nvPr/>
       </p:nvGrpSpPr>
-      <p:grpSpPr/>
+      <p:grpSpPr>
+        <a:xfrm>
+          <a:off x="0" y="0"/>
+          <a:ext cx="0" cy="0"/>
+          <a:chOff x="0" y="0"/>
+          <a:chExt cx="0" cy="0"/>
+        </a:xfrm>
+      </p:grpSpPr>
       <p:sp>
         <p:nvSpPr>
           <p:cNvPr id="2" name="TextBox 1"/>
@@ -4877,7 +4990,7 @@
 </file>
 
 <file path=ppt/slides/slide7.xml><?xml version="1.0" encoding="utf-8"?>
-<p:sld xmlns:a="http://schemas.openxmlformats.org/drawingml/2006/main" xmlns:p="http://schemas.openxmlformats.org/presentationml/2006/main" xmlns:r="http://schemas.openxmlformats.org/officeDocument/2006/relationships">
+<p:sld xmlns:a="http://schemas.openxmlformats.org/drawingml/2006/main" xmlns:r="http://schemas.openxmlformats.org/officeDocument/2006/relationships" xmlns:p="http://schemas.openxmlformats.org/presentationml/2006/main">
   <p:cSld>
     <p:bg>
       <p:bgPr>
@@ -4893,7 +5006,14 @@
         <p:cNvGrpSpPr/>
         <p:nvPr/>
       </p:nvGrpSpPr>
-      <p:grpSpPr/>
+      <p:grpSpPr>
+        <a:xfrm>
+          <a:off x="0" y="0"/>
+          <a:ext cx="0" cy="0"/>
+          <a:chOff x="0" y="0"/>
+          <a:chExt cx="0" cy="0"/>
+        </a:xfrm>
+      </p:grpSpPr>
       <p:sp>
         <p:nvSpPr>
           <p:cNvPr id="2" name="TextBox 1"/>
@@ -4924,6 +5044,7 @@
               </a:defRPr>
             </a:pPr>
             <a:r>
+              <a:rPr dirty="0"/>
               <a:t>Jury Figures, Financial ROI &amp; Future Path</a:t>
             </a:r>
           </a:p>
@@ -4936,7 +5057,12 @@
               </a:defRPr>
             </a:pPr>
             <a:r>
-              <a:t>AttriSense AI: Making the Case to Leadership</a:t>
+              <a:rPr dirty="0" err="1"/>
+              <a:t>AttriSense</a:t>
+            </a:r>
+            <a:r>
+              <a:rPr dirty="0"/>
+              <a:t> AI: Making the Case to Leadership</a:t>
             </a:r>
           </a:p>
         </p:txBody>
@@ -4962,23 +5088,23 @@
             <a:spAutoFit/>
           </a:bodyPr>
           <a:lstStyle/>
-          <a:p/>
+          <a:p>
+            <a:endParaRPr dirty="0"/>
+          </a:p>
           <a:p>
             <a:pPr>
               <a:spcAft>
                 <a:spcPts val="800"/>
               </a:spcAft>
-              <a:defRPr b="1" sz="1100">
+              <a:defRPr sz="1100" b="1">
                 <a:solidFill>
                   <a:srgbClr val="F8FAFC"/>
                 </a:solidFill>
               </a:defRPr>
             </a:pPr>
             <a:r>
-              <a:t>• Industry Landscape: </a:t>
-            </a:r>
-            <a:r>
-              <a:t>Global IT attrition averages 15% - 20%. LTTS historical attrition hovers around 13% - 18%. Healthy attrition target is 8% - 12%.</a:t>
+              <a:rPr dirty="0"/>
+              <a:t>• Industry Landscape: Global IT attrition averages 15% - 20%. LTTS historical attrition hovers around 13% - 18%. Healthy attrition target is 8% - 12%.</a:t>
             </a:r>
           </a:p>
           <a:p>
@@ -4986,17 +5112,15 @@
               <a:spcAft>
                 <a:spcPts val="800"/>
               </a:spcAft>
-              <a:defRPr b="1" sz="1100">
+              <a:defRPr sz="1100" b="1">
                 <a:solidFill>
                   <a:srgbClr val="F8FAFC"/>
                 </a:solidFill>
               </a:defRPr>
             </a:pPr>
             <a:r>
-              <a:t>• Replacing Employee Cost: </a:t>
-            </a:r>
-            <a:r>
-              <a:t>Recruitment, onboarding, productivity loss, and knowledge transfer costs average $10,000 to $15,000 per person.</a:t>
+              <a:rPr dirty="0"/>
+              <a:t>• Replacing Employee Cost: Recruitment, onboarding, productivity loss, and knowledge transfer costs average $10,000 to $15,000 per person.</a:t>
             </a:r>
           </a:p>
           <a:p>
@@ -5004,17 +5128,15 @@
               <a:spcAft>
                 <a:spcPts val="800"/>
               </a:spcAft>
-              <a:defRPr b="1" sz="1100">
+              <a:defRPr sz="1100" b="1">
                 <a:solidFill>
                   <a:srgbClr val="F8FAFC"/>
                 </a:solidFill>
               </a:defRPr>
             </a:pPr>
             <a:r>
-              <a:t>• LTTS Financial ROI Impact: </a:t>
-            </a:r>
-            <a:r>
-              <a:t>For an LTTS-sized base (~23,000 employees) at 15% attrition:
+              <a:rPr dirty="0"/>
+              <a:t>• LTTS Financial ROI Impact: For an LTTS-sized base (~23,000 employees) at 15% attrition:
 - Exits: ~3,450/year costing $34.5M to $51.75M.
 - Retaining just 10% of exiting high-performers translates to annual savings of $3.45M to $5.17M.
 - System run cost: under $12,000/year (300x+ ROI!).</a:t>
@@ -5025,17 +5147,15 @@
               <a:spcAft>
                 <a:spcPts val="800"/>
               </a:spcAft>
-              <a:defRPr b="1" sz="1100">
+              <a:defRPr sz="1100" b="1">
                 <a:solidFill>
                   <a:srgbClr val="F8FAFC"/>
                 </a:solidFill>
               </a:defRPr>
             </a:pPr>
             <a:r>
-              <a:t>• Model Accuracy: </a:t>
-            </a:r>
-            <a:r>
-              <a:t>Built and calibrated against research achieving up to 95% classification accuracy on attrition patterns.</a:t>
+              <a:rPr dirty="0"/>
+              <a:t>• Model Accuracy: Built and calibrated against research achieving up to 95% classification accuracy on attrition patterns.</a:t>
             </a:r>
           </a:p>
         </p:txBody>
@@ -5061,7 +5181,9 @@
             <a:spAutoFit/>
           </a:bodyPr>
           <a:lstStyle/>
-          <a:p/>
+          <a:p>
+            <a:endParaRPr dirty="0"/>
+          </a:p>
           <a:p>
             <a:pPr>
               <a:spcAft>
@@ -5074,18 +5196,20 @@
               </a:defRPr>
             </a:pPr>
             <a:r>
+              <a:rPr dirty="0"/>
               <a:t>🔮 Future Steps &amp; Managerial Index</a:t>
             </a:r>
           </a:p>
           <a:p>
             <a:pPr>
-              <a:defRPr b="1" sz="1400">
+              <a:defRPr sz="1400" b="1">
                 <a:solidFill>
                   <a:srgbClr val="06B6D4"/>
                 </a:solidFill>
               </a:defRPr>
             </a:pPr>
             <a:r>
+              <a:rPr dirty="0"/>
               <a:t>• Managerial Influence (16th Parameter)</a:t>
             </a:r>
           </a:p>
@@ -5101,18 +5225,20 @@
               </a:defRPr>
             </a:pPr>
             <a:r>
+              <a:rPr dirty="0"/>
               <a:t>We plan to feed a new signal measuring a manager's history: standard deviation of attrition rates in their team, average team mood ratings, and historical scorecards.</a:t>
             </a:r>
           </a:p>
           <a:p>
             <a:pPr>
-              <a:defRPr b="1" sz="1400">
+              <a:defRPr sz="1400" b="1">
                 <a:solidFill>
                   <a:srgbClr val="06B6D4"/>
                 </a:solidFill>
               </a:defRPr>
             </a:pPr>
             <a:r>
+              <a:rPr dirty="0"/>
               <a:t>• Automatic Coaching &amp; Training</a:t>
             </a:r>
           </a:p>
@@ -5128,18 +5254,20 @@
               </a:defRPr>
             </a:pPr>
             <a:r>
+              <a:rPr dirty="0"/>
               <a:t>If a manager's team shows elevated risk flags, the system proactively triggers an internal 'Leadership Development &amp; Management Coaching' program, supporting the manager with skill development rather than penalizing them.</a:t>
             </a:r>
           </a:p>
           <a:p>
             <a:pPr>
-              <a:defRPr b="1" sz="1400">
+              <a:defRPr sz="1400" b="1">
                 <a:solidFill>
                   <a:srgbClr val="06B6D4"/>
                 </a:solidFill>
               </a:defRPr>
             </a:pPr>
             <a:r>
+              <a:rPr dirty="0"/>
               <a:t>• Integrations with Corporate HRMS</a:t>
             </a:r>
           </a:p>
@@ -5155,6 +5283,7 @@
               </a:defRPr>
             </a:pPr>
             <a:r>
+              <a:rPr dirty="0"/>
               <a:t>Connect MCP server natively to Workday, SAP SuccessFactors, and local IT logs (Jira, Git, active hours telemetry) for fully automated, continuous prediction.</a:t>
             </a:r>
           </a:p>

</xml_diff>